<commit_message>
Resolve inconsistencies in the slide deck
</commit_message>
<xml_diff>
--- a/wc26-forecast-var-agent-episode2/deliverables/new_version/forecast_var_agent_engineering_deck.pptx
+++ b/wc26-forecast-var-agent-episode2/deliverables/new_version/forecast_var_agent_engineering_deck.pptx
@@ -24,8 +24,8 @@
     <p:sldId id="272" r:id="rId18"/>
     <p:sldId id="273" r:id="rId19"/>
     <p:sldId id="274" r:id="rId20"/>
+    <p:sldId id="276" r:id="rId22"/>
     <p:sldId id="275" r:id="rId21"/>
-    <p:sldId id="276" r:id="rId22"/>
     <p:sldId id="277" r:id="rId23"/>
     <p:sldId id="278" r:id="rId24"/>
     <p:sldId id="279" r:id="rId25"/>
@@ -4057,7 +4057,7 @@
                 <a:ea typeface="Aptos Display" pitchFamily="34" charset="-122"/>
                 <a:cs typeface="Aptos Display" pitchFamily="34" charset="-120"/>
               </a:rPr>
-              <a:t>Step 2 — Pre-flight gate: no forecast until the tournament context is coherent</a:t>
+              <a:t>Step 2 — Pre-flight gate: validate before RAG, tools, or forecasts</a:t>
             </a:r>
             <a:endParaRPr lang="en-US" sz="2400" dirty="0"/>
           </a:p>
@@ -4489,7 +4489,7 @@
                   <a:srgbClr val="213547"/>
                 </a:solidFill>
               </a:rPr>
-              <a:t>evidence_docs: 74</a:t>
+              <a:t>evidence_docs: 73</a:t>
             </a:r>
             <a:endParaRPr lang="en-US" sz="880" dirty="0"/>
           </a:p>
@@ -4696,7 +4696,7 @@
                 <a:ea typeface="Aptos Display" pitchFamily="34" charset="-122"/>
                 <a:cs typeface="Aptos Display" pitchFamily="34" charset="-120"/>
               </a:rPr>
-              <a:t>Step 3 — RAG: source cards make the forecast explainable before it is persuasive</a:t>
+              <a:t>Step 3 — RAG: retrieve source cards after pre-flight passes</a:t>
             </a:r>
             <a:endParaRPr lang="en-US" sz="2400" dirty="0"/>
           </a:p>
@@ -8532,7 +8532,7 @@
                 <a:ea typeface="Courier New" pitchFamily="34" charset="-122"/>
                 <a:cs typeface="Courier New" pitchFamily="34" charset="-120"/>
               </a:rPr>
-              <a:t>    diff = adjusted_rating(team_a) - adjusted_rating(team_b)</a:t>
+              <a:t xml:space="preserve">    diff = adjusted_rating(team_a) - adjusted_rating(team_b)</a:t>
             </a:r>
             <a:endParaRPr lang="en-US" sz="740" dirty="0"/>
           </a:p>
@@ -8549,7 +8549,7 @@
                 <a:ea typeface="Courier New" pitchFamily="34" charset="-122"/>
                 <a:cs typeface="Courier New" pitchFamily="34" charset="-120"/>
               </a:rPr>
-              <a:t>    p_a_no_draw = 1 / (1 + 10 ** (-diff / 420))</a:t>
+              <a:t xml:space="preserve">    p_a_no_draw = 1 / (1 + 10 ** (-diff / 420))</a:t>
             </a:r>
             <a:endParaRPr lang="en-US" sz="740" dirty="0"/>
           </a:p>
@@ -8566,7 +8566,7 @@
                 <a:ea typeface="Courier New" pitchFamily="34" charset="-122"/>
                 <a:cs typeface="Courier New" pitchFamily="34" charset="-120"/>
               </a:rPr>
-              <a:t>    draw = bounded_draw_probability(diff)</a:t>
+              <a:t xml:space="preserve">    draw = bounded_draw_probability(diff)</a:t>
             </a:r>
             <a:endParaRPr lang="en-US" sz="740" dirty="0"/>
           </a:p>
@@ -8583,7 +8583,7 @@
                 <a:ea typeface="Courier New" pitchFamily="34" charset="-122"/>
                 <a:cs typeface="Courier New" pitchFamily="34" charset="-120"/>
               </a:rPr>
-              <a:t>    return {</a:t>
+              <a:t xml:space="preserve">    p_a = (1 - draw) * p_a_no_draw</a:t>
             </a:r>
             <a:endParaRPr lang="en-US" sz="740" dirty="0"/>
           </a:p>
@@ -8600,7 +8600,7 @@
                 <a:ea typeface="Courier New" pitchFamily="34" charset="-122"/>
                 <a:cs typeface="Courier New" pitchFamily="34" charset="-120"/>
               </a:rPr>
-              <a:t>      "p_team_a_win": (1 - draw) * p_a_no_draw,</a:t>
+              <a:t xml:space="preserve">    p_b = 1 - draw - p_a</a:t>
             </a:r>
             <a:endParaRPr lang="en-US" sz="740" dirty="0"/>
           </a:p>
@@ -8617,7 +8617,7 @@
                 <a:ea typeface="Courier New" pitchFamily="34" charset="-122"/>
                 <a:cs typeface="Courier New" pitchFamily="34" charset="-120"/>
               </a:rPr>
-              <a:t>      "p_draw": draw,</a:t>
+              <a:t xml:space="preserve">    return {"p_team_a_win": p_a,</a:t>
             </a:r>
             <a:endParaRPr lang="en-US" sz="740" dirty="0"/>
           </a:p>
@@ -8634,7 +8634,7 @@
                 <a:ea typeface="Courier New" pitchFamily="34" charset="-122"/>
                 <a:cs typeface="Courier New" pitchFamily="34" charset="-120"/>
               </a:rPr>
-              <a:t>      "p_team_b_win": 1 - draw - p_a</a:t>
+              <a:t xml:space="preserve">            "p_draw": draw,</a:t>
             </a:r>
             <a:endParaRPr lang="en-US" sz="740" dirty="0"/>
           </a:p>
@@ -8651,7 +8651,7 @@
                 <a:ea typeface="Courier New" pitchFamily="34" charset="-122"/>
                 <a:cs typeface="Courier New" pitchFamily="34" charset="-120"/>
               </a:rPr>
-              <a:t>    }</a:t>
+              <a:t xml:space="preserve">            "p_team_b_win": p_b}</a:t>
             </a:r>
             <a:endParaRPr lang="en-US" sz="740" dirty="0"/>
           </a:p>
@@ -11737,7 +11737,7 @@
                 <a:ea typeface="Courier New" pitchFamily="34" charset="-122"/>
                 <a:cs typeface="Courier New" pitchFamily="34" charset="-120"/>
               </a:rPr>
-              <a:t>source cards     16 docs</a:t>
+              <a:t xml:space="preserve">source cards 15 + team features 48 docs</a:t>
             </a:r>
             <a:endParaRPr lang="en-US" sz="740" dirty="0"/>
           </a:p>
@@ -11754,7 +11754,7 @@
                 <a:ea typeface="Courier New" pitchFamily="34" charset="-122"/>
                 <a:cs typeface="Courier New" pitchFamily="34" charset="-120"/>
               </a:rPr>
-              <a:t>team features    48 docs</a:t>
+              <a:t xml:space="preserve">market odds 7 + curated notes 3 docs</a:t>
             </a:r>
             <a:endParaRPr lang="en-US" sz="740" dirty="0"/>
           </a:p>
@@ -11771,7 +11771,7 @@
                 <a:ea typeface="Courier New" pitchFamily="34" charset="-122"/>
                 <a:cs typeface="Courier New" pitchFamily="34" charset="-120"/>
               </a:rPr>
-              <a:t>market odds       7 docs</a:t>
+              <a:t xml:space="preserve"/>
             </a:r>
             <a:endParaRPr lang="en-US" sz="740" dirty="0"/>
           </a:p>
@@ -11788,7 +11788,7 @@
                 <a:ea typeface="Courier New" pitchFamily="34" charset="-122"/>
                 <a:cs typeface="Courier New" pitchFamily="34" charset="-120"/>
               </a:rPr>
-              <a:t>curated notes      3 docs</a:t>
+              <a:t/>
             </a:r>
             <a:endParaRPr lang="en-US" sz="740" dirty="0"/>
           </a:p>
@@ -13279,7 +13279,7 @@
                 <a:ea typeface="Aptos Display" pitchFamily="34" charset="-122"/>
                 <a:cs typeface="Aptos Display" pitchFamily="34" charset="-120"/>
               </a:rPr>
-              <a:t>Step 12 — Evaluation harness: the VAR room for agent behaviour</a:t>
+              <a:t>Step 13 — Evaluation harness: the VAR room for agent behaviour</a:t>
             </a:r>
             <a:endParaRPr lang="en-US" sz="2400" dirty="0"/>
           </a:p>
@@ -13875,7 +13875,7 @@
                 <a:ea typeface="Aptos Display" pitchFamily="34" charset="-122"/>
                 <a:cs typeface="Aptos Display" pitchFamily="34" charset="-120"/>
               </a:rPr>
-              <a:t>Step 13 — Structured output: make the answer machine-checkable</a:t>
+              <a:t>Step 12 — Structured output: make the answer machine-checkable</a:t>
             </a:r>
             <a:endParaRPr lang="en-US" sz="2400" dirty="0"/>
           </a:p>
@@ -14023,7 +14023,7 @@
                 <a:ea typeface="Courier New" pitchFamily="34" charset="-122"/>
                 <a:cs typeface="Courier New" pitchFamily="34" charset="-120"/>
               </a:rPr>
-              <a:t>    question: str</a:t>
+              <a:t xml:space="preserve">    answer: str</a:t>
             </a:r>
             <a:endParaRPr lang="en-US" sz="740" dirty="0"/>
           </a:p>
@@ -14040,7 +14040,7 @@
                 <a:ea typeface="Courier New" pitchFamily="34" charset="-122"/>
                 <a:cs typeface="Courier New" pitchFamily="34" charset="-120"/>
               </a:rPr>
-              <a:t>    answer: str</a:t>
+              <a:t xml:space="preserve">    claims: list[ForecastClaim]</a:t>
             </a:r>
             <a:endParaRPr lang="en-US" sz="740" dirty="0"/>
           </a:p>
@@ -14057,7 +14057,7 @@
                 <a:ea typeface="Courier New" pitchFamily="34" charset="-122"/>
                 <a:cs typeface="Courier New" pitchFamily="34" charset="-120"/>
               </a:rPr>
-              <a:t>    claims: list[Claim]</a:t>
+              <a:t xml:space="preserve">    citations: list[Citation]</a:t>
             </a:r>
             <a:endParaRPr lang="en-US" sz="740" dirty="0"/>
           </a:p>
@@ -14074,7 +14074,7 @@
                 <a:ea typeface="Courier New" pitchFamily="34" charset="-122"/>
                 <a:cs typeface="Courier New" pitchFamily="34" charset="-120"/>
               </a:rPr>
-              <a:t>    citations: list[Citation]</a:t>
+              <a:t xml:space="preserve">    tools_used: list[str]</a:t>
             </a:r>
             <a:endParaRPr lang="en-US" sz="740" dirty="0"/>
           </a:p>
@@ -14091,7 +14091,7 @@
                 <a:ea typeface="Courier New" pitchFamily="34" charset="-122"/>
                 <a:cs typeface="Courier New" pitchFamily="34" charset="-120"/>
               </a:rPr>
-              <a:t>    tools_used: list[str]</a:t>
+              <a:t xml:space="preserve">    skills_used: list[str]</a:t>
             </a:r>
             <a:endParaRPr lang="en-US" sz="740" dirty="0"/>
           </a:p>
@@ -14108,7 +14108,7 @@
                 <a:ea typeface="Courier New" pitchFamily="34" charset="-122"/>
                 <a:cs typeface="Courier New" pitchFamily="34" charset="-120"/>
               </a:rPr>
-              <a:t>    skills_used: list[str]</a:t>
+              <a:t xml:space="preserve">    probabilities: dict[str, float]</a:t>
             </a:r>
             <a:endParaRPr lang="en-US" sz="740" dirty="0"/>
           </a:p>
@@ -14125,7 +14125,7 @@
                 <a:ea typeface="Courier New" pitchFamily="34" charset="-122"/>
                 <a:cs typeface="Courier New" pitchFamily="34" charset="-120"/>
               </a:rPr>
-              <a:t>    warnings: list[str]</a:t>
+              <a:t xml:space="preserve">    abstained: bool = False</a:t>
             </a:r>
             <a:endParaRPr lang="en-US" sz="740" dirty="0"/>
           </a:p>
@@ -14142,7 +14142,24 @@
                 <a:ea typeface="Courier New" pitchFamily="34" charset="-122"/>
                 <a:cs typeface="Courier New" pitchFamily="34" charset="-120"/>
               </a:rPr>
-              <a:t>    abstained: bool</a:t>
+              <a:t xml:space="preserve">    warnings: list[str]</a:t>
+            </a:r>
+            <a:endParaRPr lang="en-US" sz="740" dirty="0"/>
+          </a:p>
+          <a:p>
+            <a:pPr indent="0" marL="0">
+              <a:buNone/>
+            </a:pPr>
+            <a:r>
+              <a:rPr lang="en-US" sz="740" dirty="0">
+                <a:solidFill>
+                  <a:srgbClr val="DDEBFF"/>
+                </a:solidFill>
+                <a:latin typeface="Courier New" pitchFamily="34" charset="0"/>
+                <a:ea typeface="Courier New" pitchFamily="34" charset="-122"/>
+                <a:cs typeface="Courier New" pitchFamily="34" charset="-120"/>
+              </a:rPr>
+              <a:t xml:space="preserve">    metadata: dict[str, Any]</a:t>
             </a:r>
             <a:endParaRPr lang="en-US" sz="740" dirty="0"/>
           </a:p>
@@ -14248,7 +14265,7 @@
                 <a:ea typeface="Courier New" pitchFamily="34" charset="-122"/>
                 <a:cs typeface="Courier New" pitchFamily="34" charset="-120"/>
               </a:rPr>
-              <a:t>class Claim(BaseModel):</a:t>
+              <a:t>class ForecastClaim(BaseModel):</a:t>
             </a:r>
             <a:endParaRPr lang="en-US" sz="740" dirty="0"/>
           </a:p>
@@ -14265,7 +14282,7 @@
                 <a:ea typeface="Courier New" pitchFamily="34" charset="-122"/>
                 <a:cs typeface="Courier New" pitchFamily="34" charset="-120"/>
               </a:rPr>
-              <a:t>    text: str</a:t>
+              <a:t xml:space="preserve">    text: str</a:t>
             </a:r>
             <a:endParaRPr lang="en-US" sz="740" dirty="0"/>
           </a:p>
@@ -14282,7 +14299,7 @@
                 <a:ea typeface="Courier New" pitchFamily="34" charset="-122"/>
                 <a:cs typeface="Courier New" pitchFamily="34" charset="-120"/>
               </a:rPr>
-              <a:t>    claim_type: Literal[</a:t>
+              <a:t xml:space="preserve">    claim_type: ClaimType</a:t>
             </a:r>
             <a:endParaRPr lang="en-US" sz="740" dirty="0"/>
           </a:p>
@@ -14299,7 +14316,7 @@
                 <a:ea typeface="Courier New" pitchFamily="34" charset="-122"/>
                 <a:cs typeface="Courier New" pitchFamily="34" charset="-120"/>
               </a:rPr>
-              <a:t>      "field_fact", "source_policy",</a:t>
+              <a:t xml:space="preserve">    citation_ids: list[str]</a:t>
             </a:r>
             <a:endParaRPr lang="en-US" sz="740" dirty="0"/>
           </a:p>
@@ -14316,7 +14333,7 @@
                 <a:ea typeface="Courier New" pitchFamily="34" charset="-122"/>
                 <a:cs typeface="Courier New" pitchFamily="34" charset="-120"/>
               </a:rPr>
-              <a:t>      "model_input", "model_output",</a:t>
+              <a:t/>
             </a:r>
             <a:endParaRPr lang="en-US" sz="740" dirty="0"/>
           </a:p>
@@ -14333,7 +14350,7 @@
                 <a:ea typeface="Courier New" pitchFamily="34" charset="-122"/>
                 <a:cs typeface="Courier New" pitchFamily="34" charset="-120"/>
               </a:rPr>
-              <a:t>      "scenario_assumption", "uncertainty",</a:t>
+              <a:t>ClaimType includes field_fact, model_input,</a:t>
             </a:r>
             <a:endParaRPr lang="en-US" sz="740" dirty="0"/>
           </a:p>
@@ -14350,7 +14367,7 @@
                 <a:ea typeface="Courier New" pitchFamily="34" charset="-122"/>
                 <a:cs typeface="Courier New" pitchFamily="34" charset="-120"/>
               </a:rPr>
-              <a:t>      "guardrail", "general"</a:t>
+              <a:t>model_output, market_baseline,</a:t>
             </a:r>
             <a:endParaRPr lang="en-US" sz="740" dirty="0"/>
           </a:p>
@@ -14367,7 +14384,7 @@
                 <a:ea typeface="Courier New" pitchFamily="34" charset="-122"/>
                 <a:cs typeface="Courier New" pitchFamily="34" charset="-120"/>
               </a:rPr>
-              <a:t>    ]</a:t>
+              <a:t>source_coverage, evidence_retrieval,</a:t>
             </a:r>
             <a:endParaRPr lang="en-US" sz="740" dirty="0"/>
           </a:p>
@@ -14384,7 +14401,41 @@
                 <a:ea typeface="Courier New" pitchFamily="34" charset="-122"/>
                 <a:cs typeface="Courier New" pitchFamily="34" charset="-120"/>
               </a:rPr>
-              <a:t>    citation_ids: list[str]</a:t>
+              <a:t>simulation_output, rolling_state,</a:t>
+            </a:r>
+            <a:endParaRPr lang="en-US" sz="740" dirty="0"/>
+          </a:p>
+          <a:p>
+            <a:pPr indent="0" marL="0">
+              <a:buNone/>
+            </a:pPr>
+            <a:r>
+              <a:rPr lang="en-US" sz="740" dirty="0">
+                <a:solidFill>
+                  <a:srgbClr val="DDEBFF"/>
+                </a:solidFill>
+                <a:latin typeface="Courier New" pitchFamily="34" charset="0"/>
+                <a:ea typeface="Courier New" pitchFamily="34" charset="-122"/>
+                <a:cs typeface="Courier New" pitchFamily="34" charset="-120"/>
+              </a:rPr>
+              <a:t>scenario_assumption, uncertainty,</a:t>
+            </a:r>
+            <a:endParaRPr lang="en-US" sz="740" dirty="0"/>
+          </a:p>
+          <a:p>
+            <a:pPr indent="0" marL="0">
+              <a:buNone/>
+            </a:pPr>
+            <a:r>
+              <a:rPr lang="en-US" sz="740" dirty="0">
+                <a:solidFill>
+                  <a:srgbClr val="DDEBFF"/>
+                </a:solidFill>
+                <a:latin typeface="Courier New" pitchFamily="34" charset="0"/>
+                <a:ea typeface="Courier New" pitchFamily="34" charset="-122"/>
+                <a:cs typeface="Courier New" pitchFamily="34" charset="-120"/>
+              </a:rPr>
+              <a:t>guardrail, source_policy, general.</a:t>
             </a:r>
             <a:endParaRPr lang="en-US" sz="740" dirty="0"/>
           </a:p>
@@ -14675,7 +14726,7 @@
                 <a:ea typeface="Aptos Display" pitchFamily="34" charset="-122"/>
                 <a:cs typeface="Aptos Display" pitchFamily="34" charset="-120"/>
               </a:rPr>
-              <a:t>Step 14 — Live OpenAI path: same pipeline, real agent model</a:t>
+              <a:t>Step 14 — Live OpenAI path: same contract, real agent model</a:t>
             </a:r>
             <a:endParaRPr lang="en-US" sz="2400" dirty="0"/>
           </a:p>
@@ -14996,6 +15047,9 @@
               <a:buNone/>
             </a:pPr>
             <a:endParaRPr lang="en-US" sz="880" dirty="0"/>
+            <a:r>
+              <a:t/>
+            </a:r>
           </a:p>
           <a:p>
             <a:pPr indent="0" marL="0">
@@ -15007,7 +15061,7 @@
                   <a:srgbClr val="213547"/>
                 </a:solidFill>
               </a:rPr>
-              <a:t>The data, tools, MCP server, source cards, simulator, structured answer schema, and post-run claim verifier remain the same.</a:t>
+              <a:t>Same sources, pre-flight, RAG, MCP tools, simulator, schema, and verifier.</a:t>
             </a:r>
             <a:endParaRPr lang="en-US" sz="880" dirty="0"/>
           </a:p>
@@ -15016,6 +15070,9 @@
               <a:buNone/>
             </a:pPr>
             <a:endParaRPr lang="en-US" sz="880" dirty="0"/>
+            <a:r>
+              <a:t/>
+            </a:r>
           </a:p>
           <a:p>
             <a:pPr indent="0" marL="0">
@@ -15027,7 +15084,7 @@
                   <a:srgbClr val="213547"/>
                 </a:solidFill>
               </a:rPr>
-              <a:t>That keeps live runs comparable with offline experiments.</a:t>
+              <a:t/>
             </a:r>
             <a:endParaRPr lang="en-US" sz="880" dirty="0"/>
           </a:p>
@@ -15262,7 +15319,7 @@
                   <a:srgbClr val="F7FAFC"/>
                 </a:solidFill>
               </a:rPr>
-              <a:t>MCP</a:t>
+              <a:t>pre-flight + RAG</a:t>
             </a:r>
             <a:endParaRPr lang="en-US" sz="900" dirty="0"/>
           </a:p>
@@ -15392,7 +15449,7 @@
                   <a:srgbClr val="F7FAFC"/>
                 </a:solidFill>
               </a:rPr>
-              <a:t>tools</a:t>
+              <a:t>MCP tools</a:t>
             </a:r>
             <a:endParaRPr lang="en-US" sz="900" dirty="0"/>
           </a:p>
@@ -15652,7 +15709,7 @@
                   <a:srgbClr val="F7FAFC"/>
                 </a:solidFill>
               </a:rPr>
-              <a:t>verifier</a:t>
+              <a:t>schema + verifier</a:t>
             </a:r>
             <a:endParaRPr lang="en-US" sz="900" dirty="0"/>
           </a:p>
@@ -15990,7 +16047,7 @@
                 <a:ea typeface="Courier New" pitchFamily="34" charset="-122"/>
                 <a:cs typeface="Courier New" pitchFamily="34" charset="-120"/>
               </a:rPr>
-              <a:t>python scripts/validate_data.py</a:t>
+              <a:t>PYTHONPATH=src python scripts/validate_data.py</a:t>
             </a:r>
             <a:endParaRPr lang="en-US" sz="740" dirty="0"/>
           </a:p>
@@ -16007,7 +16064,7 @@
                 <a:ea typeface="Courier New" pitchFamily="34" charset="-122"/>
                 <a:cs typeface="Courier New" pitchFamily="34" charset="-120"/>
               </a:rPr>
-              <a:t>python scripts/refresh_sources.py</a:t>
+              <a:t>PYTHONPATH=src python scripts/refresh_sources.py</a:t>
             </a:r>
             <a:endParaRPr lang="en-US" sz="740" dirty="0"/>
           </a:p>
@@ -16024,7 +16081,7 @@
                 <a:ea typeface="Courier New" pitchFamily="34" charset="-122"/>
                 <a:cs typeface="Courier New" pitchFamily="34" charset="-120"/>
               </a:rPr>
-              <a:t>python scripts/generate_figures.py</a:t>
+              <a:t>PYTHONPATH=src python scripts/generate_figures.py</a:t>
             </a:r>
             <a:endParaRPr lang="en-US" sz="740" dirty="0"/>
           </a:p>
@@ -16041,7 +16098,7 @@
                 <a:ea typeface="Courier New" pitchFamily="34" charset="-122"/>
                 <a:cs typeface="Courier New" pitchFamily="34" charset="-120"/>
               </a:rPr>
-              <a:t>python scripts/evaluate.py --mode grounded_mock</a:t>
+              <a:t>PYTHONPATH=src python scripts/evaluate.py --mode grounded_mock</a:t>
             </a:r>
             <a:endParaRPr lang="en-US" sz="740" dirty="0"/>
           </a:p>
@@ -16058,7 +16115,7 @@
                 <a:ea typeface="Courier New" pitchFamily="34" charset="-122"/>
                 <a:cs typeface="Courier New" pitchFamily="34" charset="-120"/>
               </a:rPr>
-              <a:t>pytest -q</a:t>
+              <a:t>PYTHONPATH=src pytest -q</a:t>
             </a:r>
             <a:endParaRPr lang="en-US" sz="740" dirty="0"/>
           </a:p>
@@ -16081,7 +16138,7 @@
                 <a:ea typeface="Courier New" pitchFamily="34" charset="-122"/>
                 <a:cs typeface="Courier New" pitchFamily="34" charset="-120"/>
               </a:rPr>
-              <a:t># Slide experiment notebook</a:t>
+              <a:t>forecast_var_deck_experiments.executed.ipynb</a:t>
             </a:r>
             <a:endParaRPr lang="en-US" sz="740" dirty="0"/>
           </a:p>
@@ -16098,7 +16155,7 @@
                 <a:ea typeface="Courier New" pitchFamily="34" charset="-122"/>
                 <a:cs typeface="Courier New" pitchFamily="34" charset="-120"/>
               </a:rPr>
-              <a:t>notebooks/forecast_var_deck_experiments.ipynb</a:t>
+              <a:t/>
             </a:r>
             <a:endParaRPr lang="en-US" sz="740" dirty="0"/>
           </a:p>
@@ -17123,7 +17180,7 @@
                   <a:srgbClr val="213547"/>
                 </a:solidFill>
               </a:rPr>
-              <a:t>Walk through sources, RAG, skills, MCP, simulation, verification.</a:t>
+              <a:t>Walk through sources, pre-flight, RAG, skills, MCP, simulation, structured claims, verification.</a:t>
             </a:r>
             <a:endParaRPr lang="en-US" sz="880" dirty="0"/>
           </a:p>
@@ -19034,7 +19091,7 @@
                   <a:srgbClr val="213547"/>
                 </a:solidFill>
               </a:rPr>
-              <a:t>RAG, skills, MCP, tools, grounding, structured output.</a:t>
+              <a:t>Source registry, pre-flight, RAG, skills, MCP, deterministic tools.</a:t>
             </a:r>
             <a:endParaRPr lang="en-US" sz="880" dirty="0"/>
           </a:p>
@@ -20322,7 +20379,7 @@
                 <a:ea typeface="Courier New" pitchFamily="34" charset="-122"/>
                 <a:cs typeface="Courier New" pitchFamily="34" charset="-120"/>
               </a:rPr>
-              <a:t>  p_team_a_win: 0.57,</a:t>
+              <a:t xml:space="preserve">  p_team_a_win: 0.5088,</a:t>
             </a:r>
             <a:endParaRPr lang="en-US" sz="740" dirty="0"/>
           </a:p>
@@ -20339,7 +20396,7 @@
                 <a:ea typeface="Courier New" pitchFamily="34" charset="-122"/>
                 <a:cs typeface="Courier New" pitchFamily="34" charset="-120"/>
               </a:rPr>
-              <a:t>  p_draw: 0.25,</a:t>
+              <a:t xml:space="preserve">  p_draw: 0.2099,</a:t>
             </a:r>
             <a:endParaRPr lang="en-US" sz="740" dirty="0"/>
           </a:p>
@@ -20356,7 +20413,7 @@
                 <a:ea typeface="Courier New" pitchFamily="34" charset="-122"/>
                 <a:cs typeface="Courier New" pitchFamily="34" charset="-120"/>
               </a:rPr>
-              <a:t>  p_team_b_win: 0.18,</a:t>
+              <a:t xml:space="preserve">  p_team_b_win: 0.2813,</a:t>
             </a:r>
             <a:endParaRPr lang="en-US" sz="740" dirty="0"/>
           </a:p>
@@ -20373,7 +20430,7 @@
                 <a:ea typeface="Courier New" pitchFamily="34" charset="-122"/>
                 <a:cs typeface="Courier New" pitchFamily="34" charset="-120"/>
               </a:rPr>
-              <a:t>  citations: ["SRC-SAMPLE-TEAM-PRIORS",</a:t>
+              <a:t xml:space="preserve">  citations: ["SRC-SAMPLE-TEAM-PRIORS",</a:t>
             </a:r>
             <a:endParaRPr lang="en-US" sz="740" dirty="0"/>
           </a:p>
@@ -20390,7 +20447,7 @@
                 <a:ea typeface="Courier New" pitchFamily="34" charset="-122"/>
                 <a:cs typeface="Courier New" pitchFamily="34" charset="-120"/>
               </a:rPr>
-              <a:t>              "MODEL-FORECAST-VAR-V1"]</a:t>
+              <a:t xml:space="preserve">              "MODEL-FORECAST-VAR-V1"]</a:t>
             </a:r>
             <a:endParaRPr lang="en-US" sz="740" dirty="0"/>
           </a:p>
@@ -21189,7 +21246,7 @@
                 <a:ea typeface="Courier New" pitchFamily="34" charset="-122"/>
                 <a:cs typeface="Courier New" pitchFamily="34" charset="-120"/>
               </a:rPr>
-              <a:t>claim_type = "model_output"</a:t>
+              <a:t>model claim → model_output</a:t>
             </a:r>
             <a:endParaRPr lang="en-US" sz="740" dirty="0"/>
           </a:p>
@@ -21206,7 +21263,24 @@
                 <a:ea typeface="Courier New" pitchFamily="34" charset="-122"/>
                 <a:cs typeface="Courier New" pitchFamily="34" charset="-120"/>
               </a:rPr>
-              <a:t>citation_ids = ["CITE-SRC-SAMPLE-MARKET-ODDS", "CITE-MODEL-FORECAST-VAR-V1"]</a:t>
+              <a:t>market claim → market_baseline</a:t>
+            </a:r>
+            <a:endParaRPr lang="en-US" sz="740" dirty="0"/>
+          </a:p>
+          <a:p>
+            <a:pPr indent="0" marL="0">
+              <a:buNone/>
+            </a:pPr>
+            <a:r>
+              <a:rPr lang="en-US" sz="740" dirty="0">
+                <a:solidFill>
+                  <a:srgbClr val="DDEBFF"/>
+                </a:solidFill>
+                <a:latin typeface="Courier New" pitchFamily="34" charset="0"/>
+                <a:ea typeface="Courier New" pitchFamily="34" charset="-122"/>
+                <a:cs typeface="Courier New" pitchFamily="34" charset="-120"/>
+              </a:rPr>
+              <a:t>citations: team priors + sample market odds + model</a:t>
             </a:r>
             <a:endParaRPr lang="en-US" sz="740" dirty="0"/>
           </a:p>
@@ -23183,7 +23257,7 @@
                 <a:ea typeface="Aptos Display" pitchFamily="34" charset="-122"/>
                 <a:cs typeface="Aptos Display" pitchFamily="34" charset="-120"/>
               </a:rPr>
-              <a:t>Full forecasting pipeline: from sources to champion probability</a:t>
+              <a:t>Full technical map: 14-step walkthrough grouped into seven runtime layers</a:t>
             </a:r>
             <a:endParaRPr lang="en-US" sz="2400" dirty="0"/>
           </a:p>
@@ -23313,7 +23387,7 @@
                   <a:srgbClr val="F7FAFC"/>
                 </a:solidFill>
               </a:rPr>
-              <a:t>Sources</a:t>
+              <a:t>Source registry</a:t>
             </a:r>
             <a:endParaRPr lang="en-US" sz="900" dirty="0"/>
           </a:p>
@@ -23443,7 +23517,7 @@
                   <a:srgbClr val="F7FAFC"/>
                 </a:solidFill>
               </a:rPr>
-              <a:t>RAG index</a:t>
+              <a:t>Pre-flight</a:t>
             </a:r>
             <a:endParaRPr lang="en-US" sz="900" dirty="0"/>
           </a:p>
@@ -23573,7 +23647,7 @@
                   <a:srgbClr val="F7FAFC"/>
                 </a:solidFill>
               </a:rPr>
-              <a:t>Skills</a:t>
+              <a:t>RAG</a:t>
             </a:r>
             <a:endParaRPr lang="en-US" sz="900" dirty="0"/>
           </a:p>
@@ -23703,7 +23777,7 @@
                   <a:srgbClr val="F7FAFC"/>
                 </a:solidFill>
               </a:rPr>
-              <a:t>MCP</a:t>
+              <a:t>Skills</a:t>
             </a:r>
             <a:endParaRPr lang="en-US" sz="900" dirty="0"/>
           </a:p>
@@ -23833,7 +23907,7 @@
                   <a:srgbClr val="F7FAFC"/>
                 </a:solidFill>
               </a:rPr>
-              <a:t>Model</a:t>
+              <a:t>MCP</a:t>
             </a:r>
             <a:endParaRPr lang="en-US" sz="900" dirty="0"/>
           </a:p>
@@ -23925,7 +23999,7 @@
                   <a:srgbClr val="D7B65D"/>
                 </a:solidFill>
               </a:rPr>
-              <a:t>6</a:t>
+              <a:t>6–11</a:t>
             </a:r>
             <a:endParaRPr lang="en-US" sz="750" dirty="0"/>
           </a:p>
@@ -23963,7 +24037,7 @@
                   <a:srgbClr val="F7FAFC"/>
                 </a:solidFill>
               </a:rPr>
-              <a:t>Claims</a:t>
+              <a:t>Forecast tools</a:t>
             </a:r>
             <a:endParaRPr lang="en-US" sz="900" dirty="0"/>
           </a:p>
@@ -24055,7 +24129,7 @@
                   <a:srgbClr val="D7B65D"/>
                 </a:solidFill>
               </a:rPr>
-              <a:t>7</a:t>
+              <a:t>12–14</a:t>
             </a:r>
             <a:endParaRPr lang="en-US" sz="750" dirty="0"/>
           </a:p>
@@ -24093,7 +24167,7 @@
                   <a:srgbClr val="F7FAFC"/>
                 </a:solidFill>
               </a:rPr>
-              <a:t>Evals</a:t>
+              <a:t>Output + QA</a:t>
             </a:r>
             <a:endParaRPr lang="en-US" sz="900" dirty="0"/>
           </a:p>
@@ -24162,7 +24236,7 @@
                   <a:srgbClr val="06142B"/>
                 </a:solidFill>
               </a:rPr>
-              <a:t>Sources</a:t>
+              <a:t>Source registry</a:t>
             </a:r>
             <a:endParaRPr lang="en-US" sz="1200" dirty="0"/>
           </a:p>
@@ -24200,7 +24274,7 @@
                   <a:srgbClr val="213547"/>
                 </a:solidFill>
               </a:rPr>
-              <a:t>FIFA groups, sample team priors, market sample, curated notes, adapter slots.</a:t>
+              <a:t>Allowed sources, statuses, demo/live policy, adapter slots.</a:t>
             </a:r>
             <a:endParaRPr lang="en-US" sz="880" dirty="0"/>
           </a:p>
@@ -24269,7 +24343,7 @@
                   <a:srgbClr val="06142B"/>
                 </a:solidFill>
               </a:rPr>
-              <a:t>RAG</a:t>
+              <a:t>Pre-flight</a:t>
             </a:r>
             <a:endParaRPr lang="en-US" sz="1200" dirty="0"/>
           </a:p>
@@ -24307,7 +24381,7 @@
                   <a:srgbClr val="213547"/>
                 </a:solidFill>
               </a:rPr>
-              <a:t>Token-overlap source-card retrieval exposes evidence before answering.</a:t>
+              <a:t>Validate field, feature rows, and evidence before retrieval or forecasting.</a:t>
             </a:r>
             <a:endParaRPr lang="en-US" sz="880" dirty="0"/>
           </a:p>
@@ -24376,7 +24450,7 @@
                   <a:srgbClr val="06142B"/>
                 </a:solidFill>
               </a:rPr>
-              <a:t>Skills</a:t>
+              <a:t>RAG</a:t>
             </a:r>
             <a:endParaRPr lang="en-US" sz="1200" dirty="0"/>
           </a:p>
@@ -24414,7 +24488,7 @@
                   <a:srgbClr val="213547"/>
                 </a:solidFill>
               </a:rPr>
-              <a:t>Small SKILL.md procedures prevent overconfident or source-free forecasts.</a:t>
+              <a:t>Retrieve source cards after pre-flight passes; evidence is candidate support.</a:t>
             </a:r>
             <a:endParaRPr lang="en-US" sz="880" dirty="0"/>
           </a:p>
@@ -24483,7 +24557,7 @@
                   <a:srgbClr val="06142B"/>
                 </a:solidFill>
               </a:rPr>
-              <a:t>MCP</a:t>
+              <a:t>Skills</a:t>
             </a:r>
             <a:endParaRPr lang="en-US" sz="1200" dirty="0"/>
           </a:p>
@@ -24521,7 +24595,7 @@
                   <a:srgbClr val="213547"/>
                 </a:solidFill>
               </a:rPr>
-              <a:t>Read-only tools create a stable boundary between agent and code.</a:t>
+              <a:t>Procedures for source triage, forecast modelling, uncertainty, and eval review.</a:t>
             </a:r>
             <a:endParaRPr lang="en-US" sz="880" dirty="0"/>
           </a:p>
@@ -24590,7 +24664,7 @@
                   <a:srgbClr val="06142B"/>
                 </a:solidFill>
               </a:rPr>
-              <a:t>Model</a:t>
+              <a:t>Forecast tools</a:t>
             </a:r>
             <a:endParaRPr lang="en-US" sz="1200" dirty="0"/>
           </a:p>
@@ -24628,7 +24702,7 @@
                   <a:srgbClr val="213547"/>
                 </a:solidFill>
               </a:rPr>
-              <a:t>Rating model + group simulation + Monte Carlo tournament engine.</a:t>
+              <a:t>Grounding split, match model, group simulation, Monte Carlo, rolling state.</a:t>
             </a:r>
             <a:endParaRPr lang="en-US" sz="880" dirty="0"/>
           </a:p>
@@ -24697,7 +24771,7 @@
                   <a:srgbClr val="06142B"/>
                 </a:solidFill>
               </a:rPr>
-              <a:t>Claims</a:t>
+              <a:t>Output + claims</a:t>
             </a:r>
             <a:endParaRPr lang="en-US" sz="1200" dirty="0"/>
           </a:p>
@@ -24735,7 +24809,7 @@
                   <a:srgbClr val="213547"/>
                 </a:solidFill>
               </a:rPr>
-              <a:t>Every sentence is typed: field_fact, model_input, model_output, uncertainty.</a:t>
+              <a:t>Structured answer with typed claims, citations, warnings, abstention, metadata.</a:t>
             </a:r>
             <a:endParaRPr lang="en-US" sz="880" dirty="0"/>
           </a:p>
@@ -24804,7 +24878,7 @@
                   <a:srgbClr val="06142B"/>
                 </a:solidFill>
               </a:rPr>
-              <a:t>Evals</a:t>
+              <a:t>Eval + live path</a:t>
             </a:r>
             <a:endParaRPr lang="en-US" sz="1200" dirty="0"/>
           </a:p>
@@ -24842,7 +24916,7 @@
                   <a:srgbClr val="213547"/>
                 </a:solidFill>
               </a:rPr>
-              <a:t>Harness checks tools, citations, support labels, abstention, and probability sanity.</a:t>
+              <a:t>Verifier and harness score support; live mode reuses the same contract.</a:t>
             </a:r>
             <a:endParaRPr lang="en-US" sz="880" dirty="0"/>
           </a:p>

</xml_diff>